<commit_message>
Updates to Python 4P
</commit_message>
<xml_diff>
--- a/python_course_4p/2_syntax_classes/2_syntax_classes.pptx
+++ b/python_course_4p/2_syntax_classes/2_syntax_classes.pptx
@@ -246,7 +246,7 @@
           <a:p>
             <a:fld id="{3BADDCAA-88FC-44D4-A91A-DD0530AB88E0}" type="datetimeFigureOut">
               <a:rPr lang="en-NL" smtClean="0"/>
-              <a:t>23/09/2026</a:t>
+              <a:t>20/10/2026</a:t>
             </a:fld>
             <a:endParaRPr lang="en-NL"/>
           </a:p>
@@ -1180,7 +1180,7 @@
           <a:p>
             <a:fld id="{0EBB069A-003F-4FC0-8534-236B0C5C7B5F}" type="datetimeFigureOut">
               <a:rPr lang="en-NL" smtClean="0"/>
-              <a:t>23/09/2026</a:t>
+              <a:t>20/10/2026</a:t>
             </a:fld>
             <a:endParaRPr lang="en-NL"/>
           </a:p>
@@ -1380,7 +1380,7 @@
           <a:p>
             <a:fld id="{0EBB069A-003F-4FC0-8534-236B0C5C7B5F}" type="datetimeFigureOut">
               <a:rPr lang="en-NL" smtClean="0"/>
-              <a:t>23/09/2026</a:t>
+              <a:t>20/10/2026</a:t>
             </a:fld>
             <a:endParaRPr lang="en-NL"/>
           </a:p>
@@ -1590,7 +1590,7 @@
           <a:p>
             <a:fld id="{0EBB069A-003F-4FC0-8534-236B0C5C7B5F}" type="datetimeFigureOut">
               <a:rPr lang="en-NL" smtClean="0"/>
-              <a:t>23/09/2026</a:t>
+              <a:t>20/10/2026</a:t>
             </a:fld>
             <a:endParaRPr lang="en-NL"/>
           </a:p>
@@ -1790,7 +1790,7 @@
           <a:p>
             <a:fld id="{0EBB069A-003F-4FC0-8534-236B0C5C7B5F}" type="datetimeFigureOut">
               <a:rPr lang="en-NL" smtClean="0"/>
-              <a:t>23/09/2026</a:t>
+              <a:t>20/10/2026</a:t>
             </a:fld>
             <a:endParaRPr lang="en-NL"/>
           </a:p>
@@ -2066,7 +2066,7 @@
           <a:p>
             <a:fld id="{0EBB069A-003F-4FC0-8534-236B0C5C7B5F}" type="datetimeFigureOut">
               <a:rPr lang="en-NL" smtClean="0"/>
-              <a:t>23/09/2026</a:t>
+              <a:t>20/10/2026</a:t>
             </a:fld>
             <a:endParaRPr lang="en-NL"/>
           </a:p>
@@ -2334,7 +2334,7 @@
           <a:p>
             <a:fld id="{0EBB069A-003F-4FC0-8534-236B0C5C7B5F}" type="datetimeFigureOut">
               <a:rPr lang="en-NL" smtClean="0"/>
-              <a:t>23/09/2026</a:t>
+              <a:t>20/10/2026</a:t>
             </a:fld>
             <a:endParaRPr lang="en-NL"/>
           </a:p>
@@ -2749,7 +2749,7 @@
           <a:p>
             <a:fld id="{0EBB069A-003F-4FC0-8534-236B0C5C7B5F}" type="datetimeFigureOut">
               <a:rPr lang="en-NL" smtClean="0"/>
-              <a:t>23/09/2026</a:t>
+              <a:t>20/10/2026</a:t>
             </a:fld>
             <a:endParaRPr lang="en-NL"/>
           </a:p>
@@ -2891,7 +2891,7 @@
           <a:p>
             <a:fld id="{0EBB069A-003F-4FC0-8534-236B0C5C7B5F}" type="datetimeFigureOut">
               <a:rPr lang="en-NL" smtClean="0"/>
-              <a:t>23/09/2026</a:t>
+              <a:t>20/10/2026</a:t>
             </a:fld>
             <a:endParaRPr lang="en-NL"/>
           </a:p>
@@ -3004,7 +3004,7 @@
           <a:p>
             <a:fld id="{0EBB069A-003F-4FC0-8534-236B0C5C7B5F}" type="datetimeFigureOut">
               <a:rPr lang="en-NL" smtClean="0"/>
-              <a:t>23/09/2026</a:t>
+              <a:t>20/10/2026</a:t>
             </a:fld>
             <a:endParaRPr lang="en-NL"/>
           </a:p>
@@ -3317,7 +3317,7 @@
           <a:p>
             <a:fld id="{0EBB069A-003F-4FC0-8534-236B0C5C7B5F}" type="datetimeFigureOut">
               <a:rPr lang="en-NL" smtClean="0"/>
-              <a:t>23/09/2026</a:t>
+              <a:t>20/10/2026</a:t>
             </a:fld>
             <a:endParaRPr lang="en-NL"/>
           </a:p>
@@ -3606,7 +3606,7 @@
           <a:p>
             <a:fld id="{0EBB069A-003F-4FC0-8534-236B0C5C7B5F}" type="datetimeFigureOut">
               <a:rPr lang="en-NL" smtClean="0"/>
-              <a:t>23/09/2026</a:t>
+              <a:t>20/10/2026</a:t>
             </a:fld>
             <a:endParaRPr lang="en-NL"/>
           </a:p>
@@ -3849,7 +3849,7 @@
           <a:p>
             <a:fld id="{0EBB069A-003F-4FC0-8534-236B0C5C7B5F}" type="datetimeFigureOut">
               <a:rPr lang="en-NL" smtClean="0"/>
-              <a:t>23/09/2026</a:t>
+              <a:t>20/10/2026</a:t>
             </a:fld>
             <a:endParaRPr lang="en-NL"/>
           </a:p>
@@ -12695,8 +12695,13 @@
           <a:p>
             <a:r>
               <a:rPr lang="nl-NL" sz="3600" noProof="0" dirty="0"/>
-              <a:t>Oefeningen II</a:t>
-            </a:r>
+              <a:t>Oefeningen </a:t>
+            </a:r>
+            <a:r>
+              <a:rPr lang="nl-NL" sz="3600" dirty="0"/>
+              <a:t>2</a:t>
+            </a:r>
+            <a:endParaRPr lang="nl-NL" sz="3600" noProof="0" dirty="0"/>
           </a:p>
         </p:txBody>
       </p:sp>
@@ -15145,7 +15150,7 @@
           <a:p>
             <a:r>
               <a:rPr lang="nl-NL" sz="3600" noProof="0" dirty="0"/>
-              <a:t>Oefeningen III</a:t>
+              <a:t>Oefeningen 3</a:t>
             </a:r>
           </a:p>
         </p:txBody>
@@ -27385,8 +27390,13 @@
           <a:p>
             <a:r>
               <a:rPr lang="nl-NL" sz="3600" noProof="0" dirty="0"/>
-              <a:t>Oefeningen IV</a:t>
-            </a:r>
+              <a:t>Oefeningen </a:t>
+            </a:r>
+            <a:r>
+              <a:rPr lang="nl-NL" sz="3600" dirty="0"/>
+              <a:t>4</a:t>
+            </a:r>
+            <a:endParaRPr lang="nl-NL" sz="3600" noProof="0" dirty="0"/>
           </a:p>
         </p:txBody>
       </p:sp>
@@ -35913,9 +35923,10 @@
           <a:lstStyle/>
           <a:p>
             <a:r>
-              <a:rPr lang="nl-NL" sz="3600" noProof="0" dirty="0"/>
-              <a:t>Oefeningen V</a:t>
-            </a:r>
+              <a:rPr lang="nl-NL" sz="3600" noProof="0"/>
+              <a:t>Oefeningen 5</a:t>
+            </a:r>
+            <a:endParaRPr lang="nl-NL" sz="3600" noProof="0" dirty="0"/>
           </a:p>
         </p:txBody>
       </p:sp>
@@ -39530,7 +39541,7 @@
           <a:p>
             <a:r>
               <a:rPr lang="nl-NL" sz="3600" noProof="0" dirty="0"/>
-              <a:t>Oefeningen I</a:t>
+              <a:t>Oefeningen 1</a:t>
             </a:r>
           </a:p>
         </p:txBody>

</xml_diff>